<commit_message>
Copyright is a master-slide placeholder above the OneLicense line, 14pt, sized for two lines
Co-authored-by: Copilot App <223556219+Copilot@users.noreply.github.com>
</commit_message>
<xml_diff>
--- a/bulletin_designer/assets/MassTemplate.pptx
+++ b/bulletin_designer/assets/MassTemplate.pptx
@@ -803,6 +803,56 @@
           </a:p>
         </p:txBody>
       </p:sp>
+      <p:sp>
+        <p:nvSpPr>
+          <p:cNvPr id="90" name="Copyright"/>
+          <p:cNvSpPr>
+            <a:spLocks noGrp="1"/>
+          </p:cNvSpPr>
+          <p:nvPr>
+            <p:ph type="body" sz="quarter" idx="11"/>
+          </p:nvPr>
+        </p:nvSpPr>
+        <p:spPr>
+          <a:xfrm>
+            <a:off x="853440" y="5588000"/>
+            <a:ext cx="10485120" cy="685800"/>
+          </a:xfrm>
+          <a:solidFill>
+            <a:srgbClr val="000000">
+              <a:alpha val="60000"/>
+            </a:srgbClr>
+          </a:solidFill>
+          <a:effectLst>
+            <a:softEdge rad="101600"/>
+          </a:effectLst>
+        </p:spPr>
+        <p:txBody>
+          <a:bodyPr anchor="b" lIns="91440" rIns="91440">
+            <a:normAutofit/>
+          </a:bodyPr>
+          <a:lstStyle>
+            <a:lvl1pPr marL="0" indent="0" algn="ctr">
+              <a:spcBef>
+                <a:spcPts val="0"/>
+              </a:spcBef>
+              <a:buNone/>
+              <a:defRPr sz="1400" b="0" i="0">
+                <a:solidFill>
+                  <a:srgbClr val="FFFFFF"/>
+                </a:solidFill>
+              </a:defRPr>
+            </a:lvl1pPr>
+          </a:lstStyle>
+          <a:p>
+            <a:pPr lvl="0"/>
+            <a:r>
+              <a:rPr lang="en-US"/>
+              <a:t>Copyright</a:t>
+            </a:r>
+          </a:p>
+        </p:txBody>
+      </p:sp>
     </p:spTree>
     <p:extLst>
       <p:ext uri="{BB962C8B-B14F-4D97-AF65-F5344CB8AC3E}">
@@ -1040,6 +1090,56 @@
             <a:r>
               <a:rPr lang="en-US" dirty="0"/>
               <a:t>Song Section</a:t>
+            </a:r>
+          </a:p>
+        </p:txBody>
+      </p:sp>
+      <p:sp>
+        <p:nvSpPr>
+          <p:cNvPr id="90" name="Copyright"/>
+          <p:cNvSpPr>
+            <a:spLocks noGrp="1"/>
+          </p:cNvSpPr>
+          <p:nvPr>
+            <p:ph type="body" sz="quarter" idx="11"/>
+          </p:nvPr>
+        </p:nvSpPr>
+        <p:spPr>
+          <a:xfrm>
+            <a:off x="853440" y="5588000"/>
+            <a:ext cx="10485120" cy="685800"/>
+          </a:xfrm>
+          <a:solidFill>
+            <a:srgbClr val="000000">
+              <a:alpha val="60000"/>
+            </a:srgbClr>
+          </a:solidFill>
+          <a:effectLst>
+            <a:softEdge rad="101600"/>
+          </a:effectLst>
+        </p:spPr>
+        <p:txBody>
+          <a:bodyPr anchor="b" lIns="91440" rIns="91440">
+            <a:normAutofit/>
+          </a:bodyPr>
+          <a:lstStyle>
+            <a:lvl1pPr marL="0" indent="0" algn="ctr">
+              <a:spcBef>
+                <a:spcPts val="0"/>
+              </a:spcBef>
+              <a:buNone/>
+              <a:defRPr sz="1400" b="0" i="0">
+                <a:solidFill>
+                  <a:srgbClr val="FFFFFF"/>
+                </a:solidFill>
+              </a:defRPr>
+            </a:lvl1pPr>
+          </a:lstStyle>
+          <a:p>
+            <a:pPr lvl="0"/>
+            <a:r>
+              <a:rPr lang="en-US"/>
+              <a:t>Copyright</a:t>
             </a:r>
           </a:p>
         </p:txBody>

</xml_diff>

<commit_message>
Copyright: dark blurred shadow on text instead of a box
Co-authored-by: Copilot App <223556219+Copilot@users.noreply.github.com>
</commit_message>
<xml_diff>
--- a/bulletin_designer/assets/MassTemplate.pptx
+++ b/bulletin_designer/assets/MassTemplate.pptx
@@ -818,14 +818,7 @@
             <a:off x="853440" y="5588000"/>
             <a:ext cx="10485120" cy="685800"/>
           </a:xfrm>
-          <a:solidFill>
-            <a:srgbClr val="000000">
-              <a:alpha val="60000"/>
-            </a:srgbClr>
-          </a:solidFill>
-          <a:effectLst>
-            <a:softEdge rad="101600"/>
-          </a:effectLst>
+          <a:noFill/>
         </p:spPr>
         <p:txBody>
           <a:bodyPr anchor="b" lIns="91440" rIns="91440">
@@ -841,6 +834,13 @@
                 <a:solidFill>
                   <a:srgbClr val="FFFFFF"/>
                 </a:solidFill>
+                <a:effectLst>
+                  <a:outerShdw blurRad="76200" dist="0" sx="115000" sy="115000" algn="ctr" rotWithShape="0">
+                    <a:srgbClr val="000000">
+                      <a:alpha val="100000"/>
+                    </a:srgbClr>
+                  </a:outerShdw>
+                </a:effectLst>
               </a:defRPr>
             </a:lvl1pPr>
           </a:lstStyle>
@@ -1109,14 +1109,7 @@
             <a:off x="853440" y="5588000"/>
             <a:ext cx="10485120" cy="685800"/>
           </a:xfrm>
-          <a:solidFill>
-            <a:srgbClr val="000000">
-              <a:alpha val="60000"/>
-            </a:srgbClr>
-          </a:solidFill>
-          <a:effectLst>
-            <a:softEdge rad="101600"/>
-          </a:effectLst>
+          <a:noFill/>
         </p:spPr>
         <p:txBody>
           <a:bodyPr anchor="b" lIns="91440" rIns="91440">
@@ -1132,6 +1125,13 @@
                 <a:solidFill>
                   <a:srgbClr val="FFFFFF"/>
                 </a:solidFill>
+                <a:effectLst>
+                  <a:outerShdw blurRad="76200" dist="0" sx="115000" sy="115000" algn="ctr" rotWithShape="0">
+                    <a:srgbClr val="000000">
+                      <a:alpha val="100000"/>
+                    </a:srgbClr>
+                  </a:outerShdw>
+                </a:effectLst>
               </a:defRPr>
             </a:lvl1pPr>
           </a:lstStyle>

</xml_diff>

<commit_message>
First-slide cover master, copyright soft return, column-photo planner honors page fit
Co-authored-by: Copilot App <223556219+Copilot@users.noreply.github.com>
</commit_message>
<xml_diff>
--- a/bulletin_designer/assets/MassTemplate.pptx
+++ b/bulletin_designer/assets/MassTemplate.pptx
@@ -1289,6 +1289,233 @@
 </p:sldLayout>
 </file>
 
+<file path=ppt/slideLayouts/slideLayout4.xml><?xml version="1.0" encoding="utf-8"?>
+<p:sldLayout xmlns:a="http://schemas.openxmlformats.org/drawingml/2006/main" xmlns:r="http://schemas.openxmlformats.org/officeDocument/2006/relationships" xmlns:p="http://schemas.openxmlformats.org/presentationml/2006/main" preserve="1" userDrawn="1">
+  <p:cSld name="Mass Cover (first slide)">
+    <p:bg>
+      <p:bgPr>
+        <a:solidFill>
+          <a:schemeClr val="tx2">
+            <a:lumMod val="75000"/>
+            <a:lumOff val="25000"/>
+          </a:schemeClr>
+        </a:solidFill>
+        <a:effectLst/>
+      </p:bgPr>
+    </p:bg>
+    <p:spTree>
+      <p:nvGrpSpPr>
+        <p:cNvPr id="1" name=""/>
+        <p:cNvGrpSpPr/>
+        <p:nvPr/>
+      </p:nvGrpSpPr>
+      <p:grpSpPr>
+        <a:xfrm>
+          <a:off x="0" y="0"/>
+          <a:ext cx="0" cy="0"/>
+          <a:chOff x="0" y="0"/>
+          <a:chExt cx="0" cy="0"/>
+        </a:xfrm>
+      </p:grpSpPr>
+      <p:sp>
+        <p:nvSpPr>
+          <p:cNvPr id="5" name="Text Placeholder 8">
+            <a:extLst>
+              <a:ext uri="{FF2B5EF4-FFF2-40B4-BE49-F238E27FC236}">
+                <a16:creationId xmlns:a16="http://schemas.microsoft.com/office/drawing/2014/main" id="{7DF2D3EA-35DD-121E-6468-45B37A8AFFD2}"/>
+              </a:ext>
+            </a:extLst>
+          </p:cNvPr>
+          <p:cNvSpPr>
+            <a:spLocks noGrp="1"/>
+          </p:cNvSpPr>
+          <p:nvPr>
+            <p:ph type="body" sz="quarter" idx="10" hasCustomPrompt="1"/>
+          </p:nvPr>
+        </p:nvSpPr>
+        <p:spPr>
+          <a:xfrm>
+            <a:off x="0" y="5650000"/>
+            <a:ext cx="12192000" cy="700000"/>
+          </a:xfrm>
+        </p:spPr>
+        <p:txBody>
+          <a:bodyPr anchor="b"/>
+          <a:lstStyle>
+            <a:lvl1pPr marL="0" indent="0" algn="ctr">
+              <a:buNone/>
+              <a:defRPr sz="3200" b="1" i="1">
+                <a:ln w="19050">
+                  <a:solidFill>
+                    <a:srgbClr val="675044"/>
+                  </a:solidFill>
+                </a:ln>
+                <a:solidFill>
+                  <a:schemeClr val="bg1"/>
+                </a:solidFill>
+                <a:effectLst>
+                  <a:glow rad="996322">
+                    <a:srgbClr val="FFC000">
+                      <a:alpha val="40000"/>
+                    </a:srgbClr>
+                  </a:glow>
+                </a:effectLst>
+                <a:latin typeface="Myriad Pro Black" panose="020B0503030403020204" pitchFamily="34" charset="0"/>
+              </a:defRPr>
+            </a:lvl1pPr>
+            <a:lvl2pPr marL="0" indent="0" algn="ctr">
+              <a:lnSpc>
+                <a:spcPct val="100000"/>
+              </a:lnSpc>
+              <a:spcBef>
+                <a:spcPts val="2000"/>
+              </a:spcBef>
+              <a:spcAft>
+                <a:spcPts val="0"/>
+              </a:spcAft>
+              <a:buNone/>
+              <a:tabLst/>
+              <a:defRPr sz="5400" b="1" i="0" baseline="0">
+                <a:ln w="3175">
+                  <a:noFill/>
+                </a:ln>
+                <a:solidFill>
+                  <a:schemeClr val="bg1"/>
+                </a:solidFill>
+                <a:effectLst>
+                  <a:outerShdw blurRad="285512" dist="66996" dir="2700000" sx="98771" sy="98771" algn="tl" rotWithShape="0">
+                    <a:prstClr val="black"/>
+                  </a:outerShdw>
+                </a:effectLst>
+                <a:latin typeface="Myriad Pro Black" panose="020B0503030403020204" pitchFamily="34" charset="0"/>
+              </a:defRPr>
+            </a:lvl2pPr>
+            <a:lvl3pPr marL="11113" indent="0" algn="ctr">
+              <a:spcBef>
+                <a:spcPts val="2000"/>
+              </a:spcBef>
+              <a:buNone/>
+              <a:tabLst/>
+              <a:defRPr b="1" i="0">
+                <a:solidFill>
+                  <a:schemeClr val="bg1"/>
+                </a:solidFill>
+                <a:effectLst>
+                  <a:outerShdw blurRad="50800" dist="38100" dir="2700000" algn="tl" rotWithShape="0">
+                    <a:prstClr val="black">
+                      <a:alpha val="40000"/>
+                    </a:prstClr>
+                  </a:outerShdw>
+                </a:effectLst>
+                <a:latin typeface="Myriad Pro Black Cond" panose="020B0503030403020204" pitchFamily="34" charset="0"/>
+              </a:defRPr>
+            </a:lvl3pPr>
+            <a:lvl4pPr>
+              <a:defRPr b="1" i="0">
+                <a:latin typeface="Myriad Pro Black Cond" panose="020B0503030403020204" pitchFamily="34" charset="0"/>
+              </a:defRPr>
+            </a:lvl4pPr>
+            <a:lvl5pPr>
+              <a:defRPr b="1" i="0">
+                <a:latin typeface="Myriad Pro Black Cond" panose="020B0503030403020204" pitchFamily="34" charset="0"/>
+              </a:defRPr>
+            </a:lvl5pPr>
+          </a:lstStyle>
+          <a:p>
+            <a:pPr lvl="0"/>
+            <a:r>
+              <a:rPr lang="en-US" dirty="0"/>
+              <a:t>Date</a:t>
+            </a:r>
+          </a:p>
+        </p:txBody>
+      </p:sp>
+      <p:sp>
+        <p:nvSpPr>
+          <p:cNvPr id="6" name="Title Placeholder 1">
+            <a:extLst>
+              <a:ext uri="{FF2B5EF4-FFF2-40B4-BE49-F238E27FC236}">
+                <a16:creationId xmlns:a16="http://schemas.microsoft.com/office/drawing/2014/main" id="{D0A1A0FF-7D7B-85AB-414E-8B8F9A92B169}"/>
+              </a:ext>
+            </a:extLst>
+          </p:cNvPr>
+          <p:cNvSpPr>
+            <a:spLocks noGrp="1"/>
+          </p:cNvSpPr>
+          <p:nvPr>
+            <p:ph type="title" hasCustomPrompt="1"/>
+          </p:nvPr>
+        </p:nvSpPr>
+        <p:spPr>
+          <a:xfrm>
+            <a:off x="0" y="365126"/>
+            <a:ext cx="12192000" cy="2400000"/>
+          </a:xfrm>
+          <a:prstGeom prst="rect">
+            <a:avLst/>
+          </a:prstGeom>
+        </p:spPr>
+        <p:txBody>
+          <a:bodyPr vert="horz" lIns="91440" tIns="45720" rIns="91440" bIns="45720" rtlCol="0" anchor="t">
+            <a:noAutofit/>
+          </a:bodyPr>
+          <a:lstStyle>
+            <a:lvl1pPr algn="ctr">
+              <a:defRPr sz="7000" b="1" i="0" spc="-300" baseline="0">
+                <a:ln w="28575">
+                  <a:solidFill>
+                    <a:srgbClr val="675044">
+                      <a:alpha val="68000"/>
+                    </a:srgbClr>
+                  </a:solidFill>
+                </a:ln>
+                <a:solidFill>
+                  <a:srgbClr val="FDF6B4"/>
+                </a:solidFill>
+                <a:effectLst>
+                  <a:outerShdw blurRad="50800" dist="100605" dir="2700000" algn="tl" rotWithShape="0">
+                    <a:prstClr val="black">
+                      <a:alpha val="25196"/>
+                    </a:prstClr>
+                  </a:outerShdw>
+                </a:effectLst>
+                <a:latin typeface="Myriad Pro Black" panose="020B0503030403020204" pitchFamily="34" charset="0"/>
+              </a:defRPr>
+            </a:lvl1pPr>
+          </a:lstStyle>
+          <a:p>
+            <a:r>
+              <a:rPr lang="en-US"/>
+              <a:t>Name of the week</a:t>
+            </a:r>
+          </a:p>
+        </p:txBody>
+      </p:sp>
+    </p:spTree>
+    <p:extLst>
+      <p:ext uri="{BB962C8B-B14F-4D97-AF65-F5344CB8AC3E}">
+        <p14:creationId xmlns:p14="http://schemas.microsoft.com/office/powerpoint/2010/main" val="3243357937"/>
+      </p:ext>
+    </p:extLst>
+  </p:cSld>
+  <p:clrMapOvr>
+    <a:masterClrMapping/>
+  </p:clrMapOvr>
+  <mc:AlternateContent xmlns:mc="http://schemas.openxmlformats.org/markup-compatibility/2006" xmlns:p14="http://schemas.microsoft.com/office/powerpoint/2010/main">
+    <mc:Choice Requires="p14">
+      <p:transition p14:dur="250">
+        <p:fade/>
+      </p:transition>
+    </mc:Choice>
+    <mc:Fallback xmlns="">
+      <p:transition>
+        <p:fade/>
+      </p:transition>
+    </mc:Fallback>
+  </mc:AlternateContent>
+</p:sldLayout>
+</file>
+
 <file path=ppt/slideMasters/slideMaster1.xml><?xml version="1.0" encoding="utf-8"?>
 <p:sldMaster xmlns:a="http://schemas.openxmlformats.org/drawingml/2006/main" xmlns:r="http://schemas.openxmlformats.org/officeDocument/2006/relationships" xmlns:p="http://schemas.openxmlformats.org/presentationml/2006/main">
   <p:cSld>
@@ -1565,6 +1792,7 @@
     <p:sldLayoutId id="2147483660" r:id="rId1"/>
     <p:sldLayoutId id="2147483661" r:id="rId2"/>
     <p:sldLayoutId id="2147483662" r:id="rId3"/>
+    <p:sldLayoutId id="2147483663" r:id="rId5"/>
   </p:sldLayoutIdLst>
   <p:txStyles>
     <p:titleStyle>

</xml_diff>